<commit_message>
Documentation for the Business Objects data flow
Comprehensively overhauled both the SOP (to complete this new version 2) and the scripts workflow diagram, to reflect the changes in process. Changes arising from the migration to: (1) extracting the data ourselves using Business Objects, and (2) aiming to do so annually rather than every three years.
</commit_message>
<xml_diff>
--- a/docs/QPI_dashboard_scripts_workflow.pptx
+++ b/docs/QPI_dashboard_scripts_workflow.pptx
@@ -9,7 +9,6 @@
     <p:sldId id="257" r:id="rId3"/>
     <p:sldId id="259" r:id="rId4"/>
     <p:sldId id="260" r:id="rId5"/>
-    <p:sldId id="261" r:id="rId6"/>
   </p:sldIdLst>
   <p:sldSz cx="12192000" cy="6858000"/>
   <p:notesSz cx="6858000" cy="9144000"/>
@@ -1094,8 +1093,16 @@
         <a:lstStyle/>
         <a:p>
           <a:r>
+            <a:rPr lang="en-GB" err="1"/>
+            <a:t>check</a:t>
+          </a:r>
+          <a:r>
+            <a:rPr lang="en-GB"/>
+            <a:t>_extracts</a:t>
+          </a:r>
+          <a:r>
             <a:rPr lang="en-GB" dirty="0" err="1"/>
-            <a:t>check_submissions.R</a:t>
+            <a:t>.R</a:t>
           </a:r>
           <a:endParaRPr lang="en-GB" dirty="0"/>
         </a:p>
@@ -1127,7 +1134,7 @@
       <dgm:prSet phldrT="[Text]"/>
       <dgm:spPr>
         <a:solidFill>
-          <a:srgbClr val="00B050"/>
+          <a:schemeClr val="accent1"/>
         </a:solidFill>
       </dgm:spPr>
       <dgm:t>
@@ -1154,47 +1161,6 @@
       </dgm:t>
     </dgm:pt>
     <dgm:pt modelId="{F75DFB2A-E316-4393-AEDB-FE67DFD41319}" type="sibTrans" cxnId="{37DBC999-B40A-4250-928A-7EC31771D853}">
-      <dgm:prSet/>
-      <dgm:spPr/>
-      <dgm:t>
-        <a:bodyPr/>
-        <a:lstStyle/>
-        <a:p>
-          <a:endParaRPr lang="en-GB"/>
-        </a:p>
-      </dgm:t>
-    </dgm:pt>
-    <dgm:pt modelId="{02DAD7B2-E388-4E3D-BE01-C42043DFCEA3}">
-      <dgm:prSet phldrT="[Text]"/>
-      <dgm:spPr>
-        <a:solidFill>
-          <a:srgbClr val="00B050"/>
-        </a:solidFill>
-      </dgm:spPr>
-      <dgm:t>
-        <a:bodyPr/>
-        <a:lstStyle/>
-        <a:p>
-          <a:r>
-            <a:rPr lang="en-GB" dirty="0" err="1"/>
-            <a:t>create_templates.R</a:t>
-          </a:r>
-          <a:endParaRPr lang="en-GB" dirty="0"/>
-        </a:p>
-      </dgm:t>
-    </dgm:pt>
-    <dgm:pt modelId="{7828FB2D-3548-4F47-9561-B3B2829979F8}" type="parTrans" cxnId="{A43DAE16-6A4F-47D6-B963-40EF8A885A1E}">
-      <dgm:prSet/>
-      <dgm:spPr/>
-      <dgm:t>
-        <a:bodyPr/>
-        <a:lstStyle/>
-        <a:p>
-          <a:endParaRPr lang="en-GB"/>
-        </a:p>
-      </dgm:t>
-    </dgm:pt>
-    <dgm:pt modelId="{8AAA0EA9-4EDE-429E-ABCA-9930A6974A73}" type="sibTrans" cxnId="{A43DAE16-6A4F-47D6-B963-40EF8A885A1E}">
       <dgm:prSet/>
       <dgm:spPr/>
       <dgm:t>
@@ -1371,6 +1337,46 @@
         </a:p>
       </dgm:t>
     </dgm:pt>
+    <dgm:pt modelId="{07287B8A-DA93-4B67-AB78-8FB1281CD425}">
+      <dgm:prSet phldrT="[Text]" phldr="0"/>
+      <dgm:spPr>
+        <a:solidFill>
+          <a:srgbClr val="00B050"/>
+        </a:solidFill>
+      </dgm:spPr>
+      <dgm:t>
+        <a:bodyPr/>
+        <a:lstStyle/>
+        <a:p>
+          <a:r>
+            <a:rPr lang="en-GB"/>
+            <a:t>generate_summary_in_excel.R</a:t>
+          </a:r>
+        </a:p>
+      </dgm:t>
+    </dgm:pt>
+    <dgm:pt modelId="{48E8F793-6DA6-49C8-860A-C9363C2342E3}" type="parTrans" cxnId="{8ED69C4B-88F9-4F0C-83B7-1A7A82D08202}">
+      <dgm:prSet/>
+      <dgm:spPr/>
+      <dgm:t>
+        <a:bodyPr/>
+        <a:lstStyle/>
+        <a:p>
+          <a:endParaRPr lang="en-GB"/>
+        </a:p>
+      </dgm:t>
+    </dgm:pt>
+    <dgm:pt modelId="{BDCB2EEB-BF02-451F-BE50-4699239BEAD5}" type="sibTrans" cxnId="{8ED69C4B-88F9-4F0C-83B7-1A7A82D08202}">
+      <dgm:prSet/>
+      <dgm:spPr/>
+      <dgm:t>
+        <a:bodyPr/>
+        <a:lstStyle/>
+        <a:p>
+          <a:endParaRPr lang="en-GB"/>
+        </a:p>
+      </dgm:t>
+    </dgm:pt>
     <dgm:pt modelId="{D887C12C-631B-4DF8-A4FA-1165D94DD5DD}" type="pres">
       <dgm:prSet presAssocID="{F19AF677-8293-414B-AA8A-7F068B9CE9CD}" presName="diagram" presStyleCnt="0">
         <dgm:presLayoutVars>
@@ -1381,7 +1387,7 @@
       <dgm:spPr/>
     </dgm:pt>
     <dgm:pt modelId="{AFAC832D-0AC8-4AAF-A620-F7870242DACB}" type="pres">
-      <dgm:prSet presAssocID="{087BCF85-2166-4625-AD57-DFDBA7BFA155}" presName="node" presStyleLbl="node1" presStyleIdx="0" presStyleCnt="12" custLinFactNeighborX="-41830" custLinFactNeighborY="861">
+      <dgm:prSet presAssocID="{087BCF85-2166-4625-AD57-DFDBA7BFA155}" presName="node" presStyleLbl="node1" presStyleIdx="0" presStyleCnt="12" custLinFactNeighborX="1781" custLinFactNeighborY="7927">
         <dgm:presLayoutVars>
           <dgm:bulletEnabled val="1"/>
         </dgm:presLayoutVars>
@@ -1393,7 +1399,7 @@
       <dgm:spPr/>
     </dgm:pt>
     <dgm:pt modelId="{74AA5DED-5F01-4427-8CF2-C3B717BFBC61}" type="pres">
-      <dgm:prSet presAssocID="{6FB0BD0E-98C4-4E8A-8586-946C799417D9}" presName="node" presStyleLbl="node1" presStyleIdx="1" presStyleCnt="12" custLinFactY="150215" custLinFactNeighborX="11269" custLinFactNeighborY="200000">
+      <dgm:prSet presAssocID="{6FB0BD0E-98C4-4E8A-8586-946C799417D9}" presName="node" presStyleLbl="node1" presStyleIdx="1" presStyleCnt="12" custLinFactX="15822" custLinFactY="100000" custLinFactNeighborX="100000" custLinFactNeighborY="182461">
         <dgm:presLayoutVars>
           <dgm:bulletEnabled val="1"/>
         </dgm:presLayoutVars>
@@ -1405,7 +1411,7 @@
       <dgm:spPr/>
     </dgm:pt>
     <dgm:pt modelId="{C33FCB6C-085A-40BA-9FDE-1329ECD67344}" type="pres">
-      <dgm:prSet presAssocID="{61BE5EBA-2E87-4703-B689-FADC9FC0E050}" presName="node" presStyleLbl="node1" presStyleIdx="2" presStyleCnt="12" custLinFactY="100000" custLinFactNeighborX="-98731" custLinFactNeighborY="146158">
+      <dgm:prSet presAssocID="{61BE5EBA-2E87-4703-B689-FADC9FC0E050}" presName="node" presStyleLbl="node1" presStyleIdx="2" presStyleCnt="12" custLinFactY="73513" custLinFactNeighborX="5160" custLinFactNeighborY="100000">
         <dgm:presLayoutVars>
           <dgm:bulletEnabled val="1"/>
         </dgm:presLayoutVars>
@@ -1417,7 +1423,7 @@
       <dgm:spPr/>
     </dgm:pt>
     <dgm:pt modelId="{50EA61F9-2696-421B-ABF3-CEF2D5D68A3C}" type="pres">
-      <dgm:prSet presAssocID="{FF0028B4-3901-48F6-B12F-65050B94DAE9}" presName="node" presStyleLbl="node1" presStyleIdx="3" presStyleCnt="12" custLinFactX="100000" custLinFactY="25961" custLinFactNeighborX="148229" custLinFactNeighborY="100000">
+      <dgm:prSet presAssocID="{FF0028B4-3901-48F6-B12F-65050B94DAE9}" presName="node" presStyleLbl="node1" presStyleIdx="3" presStyleCnt="12" custLinFactY="72887" custLinFactNeighborX="126" custLinFactNeighborY="100000">
         <dgm:presLayoutVars>
           <dgm:bulletEnabled val="1"/>
         </dgm:presLayoutVars>
@@ -1429,7 +1435,7 @@
       <dgm:spPr/>
     </dgm:pt>
     <dgm:pt modelId="{C9B1B6ED-E6FD-45A7-9BE0-649F02EF6864}" type="pres">
-      <dgm:prSet presAssocID="{9BC5AA6D-2728-4623-9F7F-6F71AD21C8EA}" presName="node" presStyleLbl="node1" presStyleIdx="4" presStyleCnt="12" custLinFactX="37902" custLinFactNeighborX="100000" custLinFactNeighborY="19692">
+      <dgm:prSet presAssocID="{9BC5AA6D-2728-4623-9F7F-6F71AD21C8EA}" presName="node" presStyleLbl="node1" presStyleIdx="4" presStyleCnt="12" custLinFactX="130126" custLinFactNeighborX="200000" custLinFactNeighborY="-50000">
         <dgm:presLayoutVars>
           <dgm:bulletEnabled val="1"/>
         </dgm:presLayoutVars>
@@ -1441,7 +1447,7 @@
       <dgm:spPr/>
     </dgm:pt>
     <dgm:pt modelId="{D6990620-1108-400B-A620-B74EF4C1DB92}" type="pres">
-      <dgm:prSet presAssocID="{7EEF316A-FF6E-4F19-95E0-42B29FB61BB2}" presName="node" presStyleLbl="node1" presStyleIdx="5" presStyleCnt="12" custLinFactX="-100000" custLinFactY="20957" custLinFactNeighborX="-129210" custLinFactNeighborY="100000">
+      <dgm:prSet presAssocID="{7EEF316A-FF6E-4F19-95E0-42B29FB61BB2}" presName="node" presStyleLbl="node1" presStyleIdx="5" presStyleCnt="12" custLinFactX="-2001" custLinFactNeighborX="-100000" custLinFactNeighborY="-42259">
         <dgm:presLayoutVars>
           <dgm:bulletEnabled val="1"/>
         </dgm:presLayoutVars>
@@ -1453,7 +1459,7 @@
       <dgm:spPr/>
     </dgm:pt>
     <dgm:pt modelId="{95310996-C784-473C-B92D-758DC78DBE68}" type="pres">
-      <dgm:prSet presAssocID="{28DD2274-AA48-4723-8F55-457C5827262F}" presName="node" presStyleLbl="node1" presStyleIdx="6" presStyleCnt="12" custLinFactY="-57687" custLinFactNeighborX="-31501" custLinFactNeighborY="-100000">
+      <dgm:prSet presAssocID="{28DD2274-AA48-4723-8F55-457C5827262F}" presName="node" presStyleLbl="node1" presStyleIdx="6" presStyleCnt="12" custLinFactX="10362" custLinFactY="-54585" custLinFactNeighborX="100000" custLinFactNeighborY="-100000">
         <dgm:presLayoutVars>
           <dgm:bulletEnabled val="1"/>
         </dgm:presLayoutVars>
@@ -1464,20 +1470,8 @@
       <dgm:prSet presAssocID="{F75DFB2A-E316-4393-AEDB-FE67DFD41319}" presName="sibTrans" presStyleCnt="0"/>
       <dgm:spPr/>
     </dgm:pt>
-    <dgm:pt modelId="{8CF59726-C47A-41EE-800B-1A4044804245}" type="pres">
-      <dgm:prSet presAssocID="{02DAD7B2-E388-4E3D-BE01-C42043DFCEA3}" presName="node" presStyleLbl="node1" presStyleIdx="7" presStyleCnt="12" custLinFactX="-29104" custLinFactNeighborX="-100000" custLinFactNeighborY="-68855">
-        <dgm:presLayoutVars>
-          <dgm:bulletEnabled val="1"/>
-        </dgm:presLayoutVars>
-      </dgm:prSet>
-      <dgm:spPr/>
-    </dgm:pt>
-    <dgm:pt modelId="{392BFBAB-B142-47BB-AE8C-A89832DF251F}" type="pres">
-      <dgm:prSet presAssocID="{8AAA0EA9-4EDE-429E-ABCA-9930A6974A73}" presName="sibTrans" presStyleCnt="0"/>
-      <dgm:spPr/>
-    </dgm:pt>
     <dgm:pt modelId="{AFEE53EB-5BC9-4377-BCBC-DEB978747400}" type="pres">
-      <dgm:prSet presAssocID="{23621A56-0650-47D0-AD64-5A90BCCE12CB}" presName="node" presStyleLbl="node1" presStyleIdx="8" presStyleCnt="12" custLinFactY="-100000" custLinFactNeighborX="-98731" custLinFactNeighborY="-131526">
+      <dgm:prSet presAssocID="{23621A56-0650-47D0-AD64-5A90BCCE12CB}" presName="node" presStyleLbl="node1" presStyleIdx="7" presStyleCnt="12" custLinFactX="-100000" custLinFactY="19931" custLinFactNeighborX="-109278" custLinFactNeighborY="100000">
         <dgm:presLayoutVars>
           <dgm:bulletEnabled val="1"/>
         </dgm:presLayoutVars>
@@ -1489,7 +1483,7 @@
       <dgm:spPr/>
     </dgm:pt>
     <dgm:pt modelId="{D8945820-A3EF-4E32-83C0-5FC7E3DEE9EE}" type="pres">
-      <dgm:prSet presAssocID="{E9BD6FEC-8AFC-4213-B86F-C30128A84BFE}" presName="node" presStyleLbl="node1" presStyleIdx="9" presStyleCnt="12" custLinFactNeighborX="4481" custLinFactNeighborY="-39427">
+      <dgm:prSet presAssocID="{E9BD6FEC-8AFC-4213-B86F-C30128A84BFE}" presName="node" presStyleLbl="node1" presStyleIdx="8" presStyleCnt="12" custLinFactNeighborX="19171" custLinFactNeighborY="-92743">
         <dgm:presLayoutVars>
           <dgm:bulletEnabled val="1"/>
         </dgm:presLayoutVars>
@@ -1500,8 +1494,20 @@
       <dgm:prSet presAssocID="{2F0F1484-1423-4E86-8E44-8FD0F6E29A4A}" presName="sibTrans" presStyleCnt="0"/>
       <dgm:spPr/>
     </dgm:pt>
+    <dgm:pt modelId="{5E683176-CE1D-4951-AE63-84F21D17C0AB}" type="pres">
+      <dgm:prSet presAssocID="{07287B8A-DA93-4B67-AB78-8FB1281CD425}" presName="node" presStyleLbl="node1" presStyleIdx="9" presStyleCnt="12" custLinFactX="-6306" custLinFactNeighborX="-100000" custLinFactNeighborY="29545">
+        <dgm:presLayoutVars>
+          <dgm:bulletEnabled val="1"/>
+        </dgm:presLayoutVars>
+      </dgm:prSet>
+      <dgm:spPr/>
+    </dgm:pt>
+    <dgm:pt modelId="{AE8892D1-38C6-4203-8173-C927A4F03A4E}" type="pres">
+      <dgm:prSet presAssocID="{BDCB2EEB-BF02-451F-BE50-4699239BEAD5}" presName="sibTrans" presStyleCnt="0"/>
+      <dgm:spPr/>
+    </dgm:pt>
     <dgm:pt modelId="{4039EB67-CC04-40F0-A707-A3A076A1A7A9}" type="pres">
-      <dgm:prSet presAssocID="{E2876B90-0FA2-49F2-A972-5CF46CF150E0}" presName="node" presStyleLbl="node1" presStyleIdx="10" presStyleCnt="12" custLinFactX="38400" custLinFactNeighborX="100000" custLinFactNeighborY="861">
+      <dgm:prSet presAssocID="{E2876B90-0FA2-49F2-A972-5CF46CF150E0}" presName="node" presStyleLbl="node1" presStyleIdx="10" presStyleCnt="12" custLinFactX="65362" custLinFactNeighborX="100000" custLinFactNeighborY="49392">
         <dgm:presLayoutVars>
           <dgm:bulletEnabled val="1"/>
         </dgm:presLayoutVars>
@@ -1513,7 +1519,7 @@
       <dgm:spPr/>
     </dgm:pt>
     <dgm:pt modelId="{D46FE4A4-C409-41F8-AC0E-1A8D4F4172F5}" type="pres">
-      <dgm:prSet presAssocID="{F98025D1-7ACC-4D14-8217-7E0BDE78AA59}" presName="node" presStyleLbl="node1" presStyleIdx="11" presStyleCnt="12" custLinFactY="-100000" custLinFactNeighborX="-98731" custLinFactNeighborY="-140994">
+      <dgm:prSet presAssocID="{F98025D1-7ACC-4D14-8217-7E0BDE78AA59}" presName="node" presStyleLbl="node1" presStyleIdx="11" presStyleCnt="12" custLinFactX="-100000" custLinFactY="-5163" custLinFactNeighborX="-109124" custLinFactNeighborY="-100000">
         <dgm:presLayoutVars>
           <dgm:bulletEnabled val="1"/>
         </dgm:presLayoutVars>
@@ -1524,14 +1530,14 @@
   <dgm:cxnLst>
     <dgm:cxn modelId="{80F48201-78F7-438F-8D85-09A8AB03F8F2}" srcId="{F19AF677-8293-414B-AA8A-7F068B9CE9CD}" destId="{9BC5AA6D-2728-4623-9F7F-6F71AD21C8EA}" srcOrd="4" destOrd="0" parTransId="{2A496C35-7BEC-4C09-A4D3-BB38DB49D8F5}" sibTransId="{28045A55-1879-4EE8-8997-069727855C29}"/>
     <dgm:cxn modelId="{AC81D80C-8CA1-4A88-93E5-448E7FD9634E}" type="presOf" srcId="{61BE5EBA-2E87-4703-B689-FADC9FC0E050}" destId="{C33FCB6C-085A-40BA-9FDE-1329ECD67344}" srcOrd="0" destOrd="0" presId="urn:microsoft.com/office/officeart/2005/8/layout/default"/>
-    <dgm:cxn modelId="{A43DAE16-6A4F-47D6-B963-40EF8A885A1E}" srcId="{F19AF677-8293-414B-AA8A-7F068B9CE9CD}" destId="{02DAD7B2-E388-4E3D-BE01-C42043DFCEA3}" srcOrd="7" destOrd="0" parTransId="{7828FB2D-3548-4F47-9561-B3B2829979F8}" sibTransId="{8AAA0EA9-4EDE-429E-ABCA-9930A6974A73}"/>
     <dgm:cxn modelId="{DABADC17-ADFB-47B9-86F3-C7F030537C0F}" srcId="{F19AF677-8293-414B-AA8A-7F068B9CE9CD}" destId="{7EEF316A-FF6E-4F19-95E0-42B29FB61BB2}" srcOrd="5" destOrd="0" parTransId="{FB4E10E2-98CE-4D3A-A036-D28931DDD75E}" sibTransId="{1B350AF1-DAF7-4354-8104-FC88D3FF7AD7}"/>
+    <dgm:cxn modelId="{F5AAA818-E94D-4376-9D81-7BB817C8F032}" type="presOf" srcId="{07287B8A-DA93-4B67-AB78-8FB1281CD425}" destId="{5E683176-CE1D-4951-AE63-84F21D17C0AB}" srcOrd="0" destOrd="0" presId="urn:microsoft.com/office/officeart/2005/8/layout/default"/>
     <dgm:cxn modelId="{779DD235-7AFC-4E5C-A576-98FFE508090D}" type="presOf" srcId="{23621A56-0650-47D0-AD64-5A90BCCE12CB}" destId="{AFEE53EB-5BC9-4377-BCBC-DEB978747400}" srcOrd="0" destOrd="0" presId="urn:microsoft.com/office/officeart/2005/8/layout/default"/>
     <dgm:cxn modelId="{D8AD4C3A-05A9-4AEA-A6C6-62650BF0B266}" type="presOf" srcId="{FF0028B4-3901-48F6-B12F-65050B94DAE9}" destId="{50EA61F9-2696-421B-ABF3-CEF2D5D68A3C}" srcOrd="0" destOrd="0" presId="urn:microsoft.com/office/officeart/2005/8/layout/default"/>
     <dgm:cxn modelId="{5BB8AB3A-89C1-4F61-BD96-7E02F4C6850C}" type="presOf" srcId="{087BCF85-2166-4625-AD57-DFDBA7BFA155}" destId="{AFAC832D-0AC8-4AAF-A620-F7870242DACB}" srcOrd="0" destOrd="0" presId="urn:microsoft.com/office/officeart/2005/8/layout/default"/>
-    <dgm:cxn modelId="{4BCA373B-F9B4-4764-9842-30A6983A3976}" srcId="{F19AF677-8293-414B-AA8A-7F068B9CE9CD}" destId="{E9BD6FEC-8AFC-4213-B86F-C30128A84BFE}" srcOrd="9" destOrd="0" parTransId="{ADFAD514-E860-4ECE-9DE5-16C59879E529}" sibTransId="{2F0F1484-1423-4E86-8E44-8FD0F6E29A4A}"/>
-    <dgm:cxn modelId="{CDCEFE47-7373-4535-A80B-3F52333682F9}" srcId="{F19AF677-8293-414B-AA8A-7F068B9CE9CD}" destId="{23621A56-0650-47D0-AD64-5A90BCCE12CB}" srcOrd="8" destOrd="0" parTransId="{B767920D-0CC2-4150-AD02-85504D3028C4}" sibTransId="{6186879A-B0F7-4F4A-A8D2-723FFA8B6D39}"/>
-    <dgm:cxn modelId="{17690D6C-CE77-4AD5-B747-9BCEFC94C21F}" type="presOf" srcId="{02DAD7B2-E388-4E3D-BE01-C42043DFCEA3}" destId="{8CF59726-C47A-41EE-800B-1A4044804245}" srcOrd="0" destOrd="0" presId="urn:microsoft.com/office/officeart/2005/8/layout/default"/>
+    <dgm:cxn modelId="{4BCA373B-F9B4-4764-9842-30A6983A3976}" srcId="{F19AF677-8293-414B-AA8A-7F068B9CE9CD}" destId="{E9BD6FEC-8AFC-4213-B86F-C30128A84BFE}" srcOrd="8" destOrd="0" parTransId="{ADFAD514-E860-4ECE-9DE5-16C59879E529}" sibTransId="{2F0F1484-1423-4E86-8E44-8FD0F6E29A4A}"/>
+    <dgm:cxn modelId="{CDCEFE47-7373-4535-A80B-3F52333682F9}" srcId="{F19AF677-8293-414B-AA8A-7F068B9CE9CD}" destId="{23621A56-0650-47D0-AD64-5A90BCCE12CB}" srcOrd="7" destOrd="0" parTransId="{B767920D-0CC2-4150-AD02-85504D3028C4}" sibTransId="{6186879A-B0F7-4F4A-A8D2-723FFA8B6D39}"/>
+    <dgm:cxn modelId="{8ED69C4B-88F9-4F0C-83B7-1A7A82D08202}" srcId="{F19AF677-8293-414B-AA8A-7F068B9CE9CD}" destId="{07287B8A-DA93-4B67-AB78-8FB1281CD425}" srcOrd="9" destOrd="0" parTransId="{48E8F793-6DA6-49C8-860A-C9363C2342E3}" sibTransId="{BDCB2EEB-BF02-451F-BE50-4699239BEAD5}"/>
     <dgm:cxn modelId="{8706AA4E-2012-4AD5-9EC3-8DC4EE145163}" type="presOf" srcId="{6FB0BD0E-98C4-4E8A-8586-946C799417D9}" destId="{74AA5DED-5F01-4427-8CF2-C3B717BFBC61}" srcOrd="0" destOrd="0" presId="urn:microsoft.com/office/officeart/2005/8/layout/default"/>
     <dgm:cxn modelId="{9F6C3E52-5F2B-413F-9B1D-BBA078E415A5}" srcId="{F19AF677-8293-414B-AA8A-7F068B9CE9CD}" destId="{6FB0BD0E-98C4-4E8A-8586-946C799417D9}" srcOrd="1" destOrd="0" parTransId="{6EC8382E-B7F6-4D86-B0A7-88D86D270544}" sibTransId="{A395FAE4-659F-4B11-80F2-01E7CFC9AF9A}"/>
     <dgm:cxn modelId="{441A445A-953A-4AE0-83D5-8A141AA403A9}" srcId="{F19AF677-8293-414B-AA8A-7F068B9CE9CD}" destId="{E2876B90-0FA2-49F2-A972-5CF46CF150E0}" srcOrd="10" destOrd="0" parTransId="{4CADFD41-398E-425C-B4CE-F474450DC7C4}" sibTransId="{A54B3D4C-101D-43E6-A8CE-CC08391DCD8C}"/>
@@ -1561,12 +1567,12 @@
     <dgm:cxn modelId="{6B5671C9-B82D-4CAA-8AB3-C2F7FE3265C7}" type="presParOf" srcId="{D887C12C-631B-4DF8-A4FA-1165D94DD5DD}" destId="{B753DD5A-FD3E-4282-9984-30F056F199DD}" srcOrd="11" destOrd="0" presId="urn:microsoft.com/office/officeart/2005/8/layout/default"/>
     <dgm:cxn modelId="{49EBA0B5-A484-4724-928D-48B3D2516655}" type="presParOf" srcId="{D887C12C-631B-4DF8-A4FA-1165D94DD5DD}" destId="{95310996-C784-473C-B92D-758DC78DBE68}" srcOrd="12" destOrd="0" presId="urn:microsoft.com/office/officeart/2005/8/layout/default"/>
     <dgm:cxn modelId="{F06145CF-4E65-4E17-A73D-64CCBF46D426}" type="presParOf" srcId="{D887C12C-631B-4DF8-A4FA-1165D94DD5DD}" destId="{39FDACEA-F193-4792-A5D1-60E4983F2DAA}" srcOrd="13" destOrd="0" presId="urn:microsoft.com/office/officeart/2005/8/layout/default"/>
-    <dgm:cxn modelId="{E0C5D7EE-284B-41A0-B53E-5B8B3164F485}" type="presParOf" srcId="{D887C12C-631B-4DF8-A4FA-1165D94DD5DD}" destId="{8CF59726-C47A-41EE-800B-1A4044804245}" srcOrd="14" destOrd="0" presId="urn:microsoft.com/office/officeart/2005/8/layout/default"/>
-    <dgm:cxn modelId="{D36AE473-B9C6-45FE-AD8D-A4DFA94B5B8E}" type="presParOf" srcId="{D887C12C-631B-4DF8-A4FA-1165D94DD5DD}" destId="{392BFBAB-B142-47BB-AE8C-A89832DF251F}" srcOrd="15" destOrd="0" presId="urn:microsoft.com/office/officeart/2005/8/layout/default"/>
-    <dgm:cxn modelId="{809A5FE3-3B27-4553-BF87-2AC91F4F280E}" type="presParOf" srcId="{D887C12C-631B-4DF8-A4FA-1165D94DD5DD}" destId="{AFEE53EB-5BC9-4377-BCBC-DEB978747400}" srcOrd="16" destOrd="0" presId="urn:microsoft.com/office/officeart/2005/8/layout/default"/>
-    <dgm:cxn modelId="{503DBC07-4772-4BD0-9955-DB27F24269F5}" type="presParOf" srcId="{D887C12C-631B-4DF8-A4FA-1165D94DD5DD}" destId="{3AE60BB2-8410-422F-AE04-F4332880F737}" srcOrd="17" destOrd="0" presId="urn:microsoft.com/office/officeart/2005/8/layout/default"/>
-    <dgm:cxn modelId="{1D834261-16EA-4261-993E-882F78C6FADB}" type="presParOf" srcId="{D887C12C-631B-4DF8-A4FA-1165D94DD5DD}" destId="{D8945820-A3EF-4E32-83C0-5FC7E3DEE9EE}" srcOrd="18" destOrd="0" presId="urn:microsoft.com/office/officeart/2005/8/layout/default"/>
-    <dgm:cxn modelId="{0E5EA343-8353-401A-A2A6-164E62F5A662}" type="presParOf" srcId="{D887C12C-631B-4DF8-A4FA-1165D94DD5DD}" destId="{7809DCB8-4E98-4001-B6EE-92DF4C4DD7D8}" srcOrd="19" destOrd="0" presId="urn:microsoft.com/office/officeart/2005/8/layout/default"/>
+    <dgm:cxn modelId="{809A5FE3-3B27-4553-BF87-2AC91F4F280E}" type="presParOf" srcId="{D887C12C-631B-4DF8-A4FA-1165D94DD5DD}" destId="{AFEE53EB-5BC9-4377-BCBC-DEB978747400}" srcOrd="14" destOrd="0" presId="urn:microsoft.com/office/officeart/2005/8/layout/default"/>
+    <dgm:cxn modelId="{503DBC07-4772-4BD0-9955-DB27F24269F5}" type="presParOf" srcId="{D887C12C-631B-4DF8-A4FA-1165D94DD5DD}" destId="{3AE60BB2-8410-422F-AE04-F4332880F737}" srcOrd="15" destOrd="0" presId="urn:microsoft.com/office/officeart/2005/8/layout/default"/>
+    <dgm:cxn modelId="{1D834261-16EA-4261-993E-882F78C6FADB}" type="presParOf" srcId="{D887C12C-631B-4DF8-A4FA-1165D94DD5DD}" destId="{D8945820-A3EF-4E32-83C0-5FC7E3DEE9EE}" srcOrd="16" destOrd="0" presId="urn:microsoft.com/office/officeart/2005/8/layout/default"/>
+    <dgm:cxn modelId="{0E5EA343-8353-401A-A2A6-164E62F5A662}" type="presParOf" srcId="{D887C12C-631B-4DF8-A4FA-1165D94DD5DD}" destId="{7809DCB8-4E98-4001-B6EE-92DF4C4DD7D8}" srcOrd="17" destOrd="0" presId="urn:microsoft.com/office/officeart/2005/8/layout/default"/>
+    <dgm:cxn modelId="{CF07853E-F0D5-433B-9460-E972436CFDE2}" type="presParOf" srcId="{D887C12C-631B-4DF8-A4FA-1165D94DD5DD}" destId="{5E683176-CE1D-4951-AE63-84F21D17C0AB}" srcOrd="18" destOrd="0" presId="urn:microsoft.com/office/officeart/2005/8/layout/default"/>
+    <dgm:cxn modelId="{9781B14B-1CE6-45C4-8B3D-14440B52CE45}" type="presParOf" srcId="{D887C12C-631B-4DF8-A4FA-1165D94DD5DD}" destId="{AE8892D1-38C6-4203-8173-C927A4F03A4E}" srcOrd="19" destOrd="0" presId="urn:microsoft.com/office/officeart/2005/8/layout/default"/>
     <dgm:cxn modelId="{070125B2-8025-4004-B634-353DD41B6F27}" type="presParOf" srcId="{D887C12C-631B-4DF8-A4FA-1165D94DD5DD}" destId="{4039EB67-CC04-40F0-A707-A3A076A1A7A9}" srcOrd="20" destOrd="0" presId="urn:microsoft.com/office/officeart/2005/8/layout/default"/>
     <dgm:cxn modelId="{C847EB68-69EC-48BA-9354-34FCBC6125B5}" type="presParOf" srcId="{D887C12C-631B-4DF8-A4FA-1165D94DD5DD}" destId="{D8B88354-C152-4A93-96AA-88714C90F80D}" srcOrd="21" destOrd="0" presId="urn:microsoft.com/office/officeart/2005/8/layout/default"/>
     <dgm:cxn modelId="{D5349C37-66DD-465A-A300-D35BFA96084D}" type="presParOf" srcId="{D887C12C-631B-4DF8-A4FA-1165D94DD5DD}" destId="{D46FE4A4-C409-41F8-AC0E-1A8D4F4172F5}" srcOrd="22" destOrd="0" presId="urn:microsoft.com/office/officeart/2005/8/layout/default"/>
@@ -1596,8 +1602,8 @@
       </dsp:nvSpPr>
       <dsp:spPr>
         <a:xfrm>
-          <a:off x="52974" y="15869"/>
-          <a:ext cx="2459260" cy="1475556"/>
+          <a:off x="53100" y="663742"/>
+          <a:ext cx="2784450" cy="1670670"/>
         </a:xfrm>
         <a:prstGeom prst="rect">
           <a:avLst/>
@@ -1634,12 +1640,12 @@
         </a:fontRef>
       </dsp:style>
       <dsp:txBody>
-        <a:bodyPr spcFirstLastPara="0" vert="horz" wrap="square" lIns="64770" tIns="64770" rIns="64770" bIns="64770" numCol="1" spcCol="1270" anchor="ctr" anchorCtr="0">
+        <a:bodyPr spcFirstLastPara="0" vert="horz" wrap="square" lIns="60960" tIns="60960" rIns="60960" bIns="60960" numCol="1" spcCol="1270" anchor="ctr" anchorCtr="0">
           <a:noAutofit/>
         </a:bodyPr>
         <a:lstStyle/>
         <a:p>
-          <a:pPr marL="0" lvl="0" indent="0" algn="ctr" defTabSz="755650">
+          <a:pPr marL="0" lvl="0" indent="0" algn="ctr" defTabSz="711200">
             <a:lnSpc>
               <a:spcPct val="90000"/>
             </a:lnSpc>
@@ -1652,15 +1658,15 @@
             <a:buNone/>
           </a:pPr>
           <a:r>
-            <a:rPr lang="en-GB" sz="1700" kern="1200" dirty="0" err="1"/>
+            <a:rPr lang="en-GB" sz="1600" kern="1200" dirty="0" err="1"/>
             <a:t>housekeeping.R</a:t>
           </a:r>
-          <a:endParaRPr lang="en-GB" sz="1700" kern="1200" dirty="0"/>
+          <a:endParaRPr lang="en-GB" sz="1600" kern="1200" dirty="0"/>
         </a:p>
       </dsp:txBody>
       <dsp:txXfrm>
-        <a:off x="52974" y="15869"/>
-        <a:ext cx="2459260" cy="1475556"/>
+        <a:off x="53100" y="663742"/>
+        <a:ext cx="2784450" cy="1670670"/>
       </dsp:txXfrm>
     </dsp:sp>
     <dsp:sp modelId="{74AA5DED-5F01-4427-8CF2-C3B717BFBC61}">
@@ -1670,8 +1676,8 @@
       </dsp:nvSpPr>
       <dsp:spPr>
         <a:xfrm>
-          <a:off x="4064003" y="5170777"/>
-          <a:ext cx="2459260" cy="1475556"/>
+          <a:off x="6291412" y="4960847"/>
+          <a:ext cx="2784450" cy="1670670"/>
         </a:xfrm>
         <a:prstGeom prst="rect">
           <a:avLst/>
@@ -1708,12 +1714,12 @@
         </a:fontRef>
       </dsp:style>
       <dsp:txBody>
-        <a:bodyPr spcFirstLastPara="0" vert="horz" wrap="square" lIns="64770" tIns="64770" rIns="64770" bIns="64770" numCol="1" spcCol="1270" anchor="ctr" anchorCtr="0">
+        <a:bodyPr spcFirstLastPara="0" vert="horz" wrap="square" lIns="60960" tIns="60960" rIns="60960" bIns="60960" numCol="1" spcCol="1270" anchor="ctr" anchorCtr="0">
           <a:noAutofit/>
         </a:bodyPr>
         <a:lstStyle/>
         <a:p>
-          <a:pPr marL="0" lvl="0" indent="0" algn="ctr" defTabSz="755650">
+          <a:pPr marL="0" lvl="0" indent="0" algn="ctr" defTabSz="711200">
             <a:lnSpc>
               <a:spcPct val="90000"/>
             </a:lnSpc>
@@ -1726,15 +1732,15 @@
             <a:buNone/>
           </a:pPr>
           <a:r>
-            <a:rPr lang="en-GB" sz="1700" kern="1200" dirty="0" err="1"/>
+            <a:rPr lang="en-GB" sz="1600" kern="1200" dirty="0" err="1"/>
             <a:t>age_gender.R</a:t>
           </a:r>
-          <a:endParaRPr lang="en-GB" sz="1700" kern="1200" dirty="0"/>
+          <a:endParaRPr lang="en-GB" sz="1600" kern="1200" dirty="0"/>
         </a:p>
       </dsp:txBody>
       <dsp:txXfrm>
-        <a:off x="4064003" y="5170777"/>
-        <a:ext cx="2459260" cy="1475556"/>
+        <a:off x="6291412" y="4960847"/>
+        <a:ext cx="2784450" cy="1670670"/>
       </dsp:txXfrm>
     </dsp:sp>
     <dsp:sp modelId="{C33FCB6C-085A-40BA-9FDE-1329ECD67344}">
@@ -1744,8 +1750,8 @@
       </dsp:nvSpPr>
       <dsp:spPr>
         <a:xfrm>
-          <a:off x="4064003" y="3635365"/>
-          <a:ext cx="2459260" cy="1475556"/>
+          <a:off x="6272979" y="3430138"/>
+          <a:ext cx="2784450" cy="1670670"/>
         </a:xfrm>
         <a:prstGeom prst="rect">
           <a:avLst/>
@@ -1782,12 +1788,12 @@
         </a:fontRef>
       </dsp:style>
       <dsp:txBody>
-        <a:bodyPr spcFirstLastPara="0" vert="horz" wrap="square" lIns="64770" tIns="64770" rIns="64770" bIns="64770" numCol="1" spcCol="1270" anchor="ctr" anchorCtr="0">
+        <a:bodyPr spcFirstLastPara="0" vert="horz" wrap="square" lIns="60960" tIns="60960" rIns="60960" bIns="60960" numCol="1" spcCol="1270" anchor="ctr" anchorCtr="0">
           <a:noAutofit/>
         </a:bodyPr>
         <a:lstStyle/>
         <a:p>
-          <a:pPr marL="0" lvl="0" indent="0" algn="ctr" defTabSz="755650">
+          <a:pPr marL="0" lvl="0" indent="0" algn="ctr" defTabSz="711200">
             <a:lnSpc>
               <a:spcPct val="90000"/>
             </a:lnSpc>
@@ -1800,15 +1806,15 @@
             <a:buNone/>
           </a:pPr>
           <a:r>
-            <a:rPr lang="en-GB" sz="1700" kern="1200" dirty="0" err="1"/>
+            <a:rPr lang="en-GB" sz="1600" kern="1200" dirty="0" err="1"/>
             <a:t>case_asc.R</a:t>
           </a:r>
-          <a:endParaRPr lang="en-GB" sz="1700" kern="1200" dirty="0"/>
+          <a:endParaRPr lang="en-GB" sz="1600" kern="1200" dirty="0"/>
         </a:p>
       </dsp:txBody>
       <dsp:txXfrm>
-        <a:off x="4064003" y="3635365"/>
-        <a:ext cx="2459260" cy="1475556"/>
+        <a:off x="6272979" y="3430138"/>
+        <a:ext cx="2784450" cy="1670670"/>
       </dsp:txXfrm>
     </dsp:sp>
     <dsp:sp modelId="{50EA61F9-2696-421B-ABF3-CEF2D5D68A3C}">
@@ -1818,8 +1824,8 @@
       </dsp:nvSpPr>
       <dsp:spPr>
         <a:xfrm>
-          <a:off x="7186281" y="3583273"/>
-          <a:ext cx="2459260" cy="1475556"/>
+          <a:off x="9195705" y="3419680"/>
+          <a:ext cx="2784450" cy="1670670"/>
         </a:xfrm>
         <a:prstGeom prst="rect">
           <a:avLst/>
@@ -1861,12 +1867,12 @@
         </a:fontRef>
       </dsp:style>
       <dsp:txBody>
-        <a:bodyPr spcFirstLastPara="0" vert="horz" wrap="square" lIns="64770" tIns="64770" rIns="64770" bIns="64770" numCol="1" spcCol="1270" anchor="ctr" anchorCtr="0">
+        <a:bodyPr spcFirstLastPara="0" vert="horz" wrap="square" lIns="60960" tIns="60960" rIns="60960" bIns="60960" numCol="1" spcCol="1270" anchor="ctr" anchorCtr="0">
           <a:noAutofit/>
         </a:bodyPr>
         <a:lstStyle/>
         <a:p>
-          <a:pPr marL="0" lvl="0" indent="0" algn="ctr" defTabSz="755650">
+          <a:pPr marL="0" lvl="0" indent="0" algn="ctr" defTabSz="711200">
             <a:lnSpc>
               <a:spcPct val="90000"/>
             </a:lnSpc>
@@ -1879,15 +1885,15 @@
             <a:buNone/>
           </a:pPr>
           <a:r>
-            <a:rPr lang="en-GB" sz="1700" kern="1200" dirty="0" err="1"/>
+            <a:rPr lang="en-GB" sz="1600" kern="1200" dirty="0" err="1"/>
             <a:t>change_hospital_names.R</a:t>
           </a:r>
-          <a:endParaRPr lang="en-GB" sz="1700" kern="1200" dirty="0"/>
+          <a:endParaRPr lang="en-GB" sz="1600" kern="1200" dirty="0"/>
         </a:p>
       </dsp:txBody>
       <dsp:txXfrm>
-        <a:off x="7186281" y="3583273"/>
-        <a:ext cx="2459260" cy="1475556"/>
+        <a:off x="9195705" y="3419680"/>
+        <a:ext cx="2784450" cy="1670670"/>
       </dsp:txXfrm>
     </dsp:sp>
     <dsp:sp modelId="{C9B1B6ED-E6FD-45A7-9BE0-649F02EF6864}">
@@ -1897,8 +1903,8 @@
       </dsp:nvSpPr>
       <dsp:spPr>
         <a:xfrm>
-          <a:off x="7178239" y="2015214"/>
-          <a:ext cx="2459260" cy="1475556"/>
+          <a:off x="9195705" y="1645088"/>
+          <a:ext cx="2784450" cy="1670670"/>
         </a:xfrm>
         <a:prstGeom prst="rect">
           <a:avLst/>
@@ -1940,12 +1946,12 @@
         </a:fontRef>
       </dsp:style>
       <dsp:txBody>
-        <a:bodyPr spcFirstLastPara="0" vert="horz" wrap="square" lIns="64770" tIns="64770" rIns="64770" bIns="64770" numCol="1" spcCol="1270" anchor="ctr" anchorCtr="0">
+        <a:bodyPr spcFirstLastPara="0" vert="horz" wrap="square" lIns="60960" tIns="60960" rIns="60960" bIns="60960" numCol="1" spcCol="1270" anchor="ctr" anchorCtr="0">
           <a:noAutofit/>
         </a:bodyPr>
         <a:lstStyle/>
         <a:p>
-          <a:pPr marL="0" lvl="0" indent="0" algn="ctr" defTabSz="755650">
+          <a:pPr marL="0" lvl="0" indent="0" algn="ctr" defTabSz="711200">
             <a:lnSpc>
               <a:spcPct val="90000"/>
             </a:lnSpc>
@@ -1958,15 +1964,15 @@
             <a:buNone/>
           </a:pPr>
           <a:r>
-            <a:rPr lang="en-GB" sz="1700" kern="1200" dirty="0" err="1"/>
+            <a:rPr lang="en-GB" sz="1600" kern="1200" dirty="0" err="1"/>
             <a:t>change_qpi_names.R</a:t>
           </a:r>
-          <a:endParaRPr lang="en-GB" sz="1700" kern="1200" dirty="0"/>
+          <a:endParaRPr lang="en-GB" sz="1600" kern="1200" dirty="0"/>
         </a:p>
       </dsp:txBody>
       <dsp:txXfrm>
-        <a:off x="7178239" y="2015214"/>
-        <a:ext cx="2459260" cy="1475556"/>
+        <a:off x="9195705" y="1645088"/>
+        <a:ext cx="2784450" cy="1670670"/>
       </dsp:txXfrm>
     </dsp:sp>
     <dsp:sp modelId="{D6990620-1108-400B-A620-B74EF4C1DB92}">
@@ -1976,8 +1982,8 @@
       </dsp:nvSpPr>
       <dsp:spPr>
         <a:xfrm>
-          <a:off x="855184" y="3509436"/>
-          <a:ext cx="2459260" cy="1475556"/>
+          <a:off x="226238" y="1774415"/>
+          <a:ext cx="2784450" cy="1670670"/>
         </a:xfrm>
         <a:prstGeom prst="rect">
           <a:avLst/>
@@ -2014,12 +2020,12 @@
         </a:fontRef>
       </dsp:style>
       <dsp:txBody>
-        <a:bodyPr spcFirstLastPara="0" vert="horz" wrap="square" lIns="64770" tIns="64770" rIns="64770" bIns="64770" numCol="1" spcCol="1270" anchor="ctr" anchorCtr="0">
+        <a:bodyPr spcFirstLastPara="0" vert="horz" wrap="square" lIns="60960" tIns="60960" rIns="60960" bIns="60960" numCol="1" spcCol="1270" anchor="ctr" anchorCtr="0">
           <a:noAutofit/>
         </a:bodyPr>
         <a:lstStyle/>
         <a:p>
-          <a:pPr marL="0" lvl="0" indent="0" algn="ctr" defTabSz="755650">
+          <a:pPr marL="0" lvl="0" indent="0" algn="ctr" defTabSz="711200">
             <a:lnSpc>
               <a:spcPct val="90000"/>
             </a:lnSpc>
@@ -2032,15 +2038,23 @@
             <a:buNone/>
           </a:pPr>
           <a:r>
-            <a:rPr lang="en-GB" sz="1700" kern="1200" dirty="0" err="1"/>
-            <a:t>check_submissions.R</a:t>
+            <a:rPr lang="en-GB" sz="1600" kern="1200" err="1"/>
+            <a:t>check</a:t>
           </a:r>
-          <a:endParaRPr lang="en-GB" sz="1700" kern="1200" dirty="0"/>
+          <a:r>
+            <a:rPr lang="en-GB" sz="1600" kern="1200"/>
+            <a:t>_extracts</a:t>
+          </a:r>
+          <a:r>
+            <a:rPr lang="en-GB" sz="1600" kern="1200" dirty="0" err="1"/>
+            <a:t>.R</a:t>
+          </a:r>
+          <a:endParaRPr lang="en-GB" sz="1600" kern="1200" dirty="0"/>
         </a:p>
       </dsp:txBody>
       <dsp:txXfrm>
-        <a:off x="855184" y="3509436"/>
-        <a:ext cx="2459260" cy="1475556"/>
+        <a:off x="226238" y="1774415"/>
+        <a:ext cx="2784450" cy="1670670"/>
       </dsp:txXfrm>
     </dsp:sp>
     <dsp:sp modelId="{95310996-C784-473C-B92D-758DC78DBE68}">
@@ -2050,14 +2064,14 @@
       </dsp:nvSpPr>
       <dsp:spPr>
         <a:xfrm>
-          <a:off x="306991" y="1119369"/>
-          <a:ext cx="2459260" cy="1475556"/>
+          <a:off x="9195707" y="0"/>
+          <a:ext cx="2784450" cy="1670670"/>
         </a:xfrm>
         <a:prstGeom prst="rect">
           <a:avLst/>
         </a:prstGeom>
         <a:solidFill>
-          <a:srgbClr val="00B050"/>
+          <a:schemeClr val="accent1"/>
         </a:solidFill>
         <a:ln w="12700" cap="flat" cmpd="sng" algn="ctr">
           <a:solidFill>
@@ -2088,12 +2102,12 @@
         </a:fontRef>
       </dsp:style>
       <dsp:txBody>
-        <a:bodyPr spcFirstLastPara="0" vert="horz" wrap="square" lIns="64770" tIns="64770" rIns="64770" bIns="64770" numCol="1" spcCol="1270" anchor="ctr" anchorCtr="0">
+        <a:bodyPr spcFirstLastPara="0" vert="horz" wrap="square" lIns="60960" tIns="60960" rIns="60960" bIns="60960" numCol="1" spcCol="1270" anchor="ctr" anchorCtr="0">
           <a:noAutofit/>
         </a:bodyPr>
         <a:lstStyle/>
         <a:p>
-          <a:pPr marL="0" lvl="0" indent="0" algn="ctr" defTabSz="755650">
+          <a:pPr marL="0" lvl="0" indent="0" algn="ctr" defTabSz="711200">
             <a:lnSpc>
               <a:spcPct val="90000"/>
             </a:lnSpc>
@@ -2106,89 +2120,15 @@
             <a:buNone/>
           </a:pPr>
           <a:r>
-            <a:rPr lang="en-GB" sz="1700" kern="1200" dirty="0" err="1"/>
+            <a:rPr lang="en-GB" sz="1600" kern="1200" dirty="0" err="1"/>
             <a:t>create_lookup.R</a:t>
           </a:r>
-          <a:endParaRPr lang="en-GB" sz="1700" kern="1200" dirty="0"/>
+          <a:endParaRPr lang="en-GB" sz="1600" kern="1200" dirty="0"/>
         </a:p>
       </dsp:txBody>
       <dsp:txXfrm>
-        <a:off x="306991" y="1119369"/>
-        <a:ext cx="2459260" cy="1475556"/>
-      </dsp:txXfrm>
-    </dsp:sp>
-    <dsp:sp modelId="{8CF59726-C47A-41EE-800B-1A4044804245}">
-      <dsp:nvSpPr>
-        <dsp:cNvPr id="0" name=""/>
-        <dsp:cNvSpPr/>
-      </dsp:nvSpPr>
-      <dsp:spPr>
-        <a:xfrm>
-          <a:off x="611865" y="2430135"/>
-          <a:ext cx="2459260" cy="1475556"/>
-        </a:xfrm>
-        <a:prstGeom prst="rect">
-          <a:avLst/>
-        </a:prstGeom>
-        <a:solidFill>
-          <a:srgbClr val="00B050"/>
-        </a:solidFill>
-        <a:ln w="12700" cap="flat" cmpd="sng" algn="ctr">
-          <a:solidFill>
-            <a:schemeClr val="lt1">
-              <a:hueOff val="0"/>
-              <a:satOff val="0"/>
-              <a:lumOff val="0"/>
-              <a:alphaOff val="0"/>
-            </a:schemeClr>
-          </a:solidFill>
-          <a:prstDash val="solid"/>
-          <a:miter lim="800000"/>
-        </a:ln>
-        <a:effectLst/>
-      </dsp:spPr>
-      <dsp:style>
-        <a:lnRef idx="2">
-          <a:scrgbClr r="0" g="0" b="0"/>
-        </a:lnRef>
-        <a:fillRef idx="1">
-          <a:scrgbClr r="0" g="0" b="0"/>
-        </a:fillRef>
-        <a:effectRef idx="0">
-          <a:scrgbClr r="0" g="0" b="0"/>
-        </a:effectRef>
-        <a:fontRef idx="minor">
-          <a:schemeClr val="lt1"/>
-        </a:fontRef>
-      </dsp:style>
-      <dsp:txBody>
-        <a:bodyPr spcFirstLastPara="0" vert="horz" wrap="square" lIns="64770" tIns="64770" rIns="64770" bIns="64770" numCol="1" spcCol="1270" anchor="ctr" anchorCtr="0">
-          <a:noAutofit/>
-        </a:bodyPr>
-        <a:lstStyle/>
-        <a:p>
-          <a:pPr marL="0" lvl="0" indent="0" algn="ctr" defTabSz="755650">
-            <a:lnSpc>
-              <a:spcPct val="90000"/>
-            </a:lnSpc>
-            <a:spcBef>
-              <a:spcPct val="0"/>
-            </a:spcBef>
-            <a:spcAft>
-              <a:spcPct val="35000"/>
-            </a:spcAft>
-            <a:buNone/>
-          </a:pPr>
-          <a:r>
-            <a:rPr lang="en-GB" sz="1700" kern="1200" dirty="0" err="1"/>
-            <a:t>create_templates.R</a:t>
-          </a:r>
-          <a:endParaRPr lang="en-GB" sz="1700" kern="1200" dirty="0"/>
-        </a:p>
-      </dsp:txBody>
-      <dsp:txXfrm>
-        <a:off x="611865" y="2430135"/>
-        <a:ext cx="2459260" cy="1475556"/>
+        <a:off x="9195707" y="0"/>
+        <a:ext cx="2784450" cy="1670670"/>
       </dsp:txXfrm>
     </dsp:sp>
     <dsp:sp modelId="{AFEE53EB-5BC9-4377-BCBC-DEB978747400}">
@@ -2198,8 +2138,8 @@
       </dsp:nvSpPr>
       <dsp:spPr>
         <a:xfrm>
-          <a:off x="4064003" y="29833"/>
-          <a:ext cx="2459260" cy="1475556"/>
+          <a:off x="3364954" y="4484075"/>
+          <a:ext cx="2784450" cy="1670670"/>
         </a:xfrm>
         <a:prstGeom prst="rect">
           <a:avLst/>
@@ -2239,12 +2179,12 @@
         </a:fontRef>
       </dsp:style>
       <dsp:txBody>
-        <a:bodyPr spcFirstLastPara="0" vert="horz" wrap="square" lIns="64770" tIns="64770" rIns="64770" bIns="64770" numCol="1" spcCol="1270" anchor="ctr" anchorCtr="0">
+        <a:bodyPr spcFirstLastPara="0" vert="horz" wrap="square" lIns="60960" tIns="60960" rIns="60960" bIns="60960" numCol="1" spcCol="1270" anchor="ctr" anchorCtr="0">
           <a:noAutofit/>
         </a:bodyPr>
         <a:lstStyle/>
         <a:p>
-          <a:pPr marL="0" lvl="0" indent="0" algn="ctr" defTabSz="755650">
+          <a:pPr marL="0" lvl="0" indent="0" algn="ctr" defTabSz="711200">
             <a:lnSpc>
               <a:spcPct val="90000"/>
             </a:lnSpc>
@@ -2257,15 +2197,15 @@
             <a:buNone/>
           </a:pPr>
           <a:r>
-            <a:rPr lang="en-GB" sz="1700" kern="1200" dirty="0" err="1"/>
+            <a:rPr lang="en-GB" sz="1600" kern="1200" dirty="0" err="1"/>
             <a:t>functions.R</a:t>
           </a:r>
-          <a:endParaRPr lang="en-GB" sz="1700" kern="1200" dirty="0"/>
+          <a:endParaRPr lang="en-GB" sz="1600" kern="1200" dirty="0"/>
         </a:p>
       </dsp:txBody>
       <dsp:txXfrm>
-        <a:off x="4064003" y="29833"/>
-        <a:ext cx="2459260" cy="1475556"/>
+        <a:off x="3364954" y="4484075"/>
+        <a:ext cx="2784450" cy="1670670"/>
       </dsp:txXfrm>
     </dsp:sp>
     <dsp:sp modelId="{D8945820-A3EF-4E32-83C0-5FC7E3DEE9EE}">
@@ -2275,8 +2215,8 @@
       </dsp:nvSpPr>
       <dsp:spPr>
         <a:xfrm>
-          <a:off x="1191882" y="4585844"/>
-          <a:ext cx="2459260" cy="1475556"/>
+          <a:off x="537316" y="2880109"/>
+          <a:ext cx="2784450" cy="1670670"/>
         </a:xfrm>
         <a:prstGeom prst="rect">
           <a:avLst/>
@@ -2313,12 +2253,12 @@
         </a:fontRef>
       </dsp:style>
       <dsp:txBody>
-        <a:bodyPr spcFirstLastPara="0" vert="horz" wrap="square" lIns="64770" tIns="64770" rIns="64770" bIns="64770" numCol="1" spcCol="1270" anchor="ctr" anchorCtr="0">
+        <a:bodyPr spcFirstLastPara="0" vert="horz" wrap="square" lIns="60960" tIns="60960" rIns="60960" bIns="60960" numCol="1" spcCol="1270" anchor="ctr" anchorCtr="0">
           <a:noAutofit/>
         </a:bodyPr>
         <a:lstStyle/>
         <a:p>
-          <a:pPr marL="0" lvl="0" indent="0" algn="ctr" defTabSz="755650">
+          <a:pPr marL="0" lvl="0" indent="0" algn="ctr" defTabSz="711200">
             <a:lnSpc>
               <a:spcPct val="90000"/>
             </a:lnSpc>
@@ -2331,15 +2271,88 @@
             <a:buNone/>
           </a:pPr>
           <a:r>
-            <a:rPr lang="en-GB" sz="1700" kern="1200" dirty="0" err="1"/>
+            <a:rPr lang="en-GB" sz="1600" kern="1200" dirty="0" err="1"/>
             <a:t>hb_hosp_qpi.R</a:t>
           </a:r>
-          <a:endParaRPr lang="en-GB" sz="1700" kern="1200" dirty="0"/>
+          <a:endParaRPr lang="en-GB" sz="1600" kern="1200" dirty="0"/>
         </a:p>
       </dsp:txBody>
       <dsp:txXfrm>
-        <a:off x="1191882" y="4585844"/>
-        <a:ext cx="2459260" cy="1475556"/>
+        <a:off x="537316" y="2880109"/>
+        <a:ext cx="2784450" cy="1670670"/>
+      </dsp:txXfrm>
+    </dsp:sp>
+    <dsp:sp modelId="{5E683176-CE1D-4951-AE63-84F21D17C0AB}">
+      <dsp:nvSpPr>
+        <dsp:cNvPr id="0" name=""/>
+        <dsp:cNvSpPr/>
+      </dsp:nvSpPr>
+      <dsp:spPr>
+        <a:xfrm>
+          <a:off x="106367" y="4923138"/>
+          <a:ext cx="2784450" cy="1670670"/>
+        </a:xfrm>
+        <a:prstGeom prst="rect">
+          <a:avLst/>
+        </a:prstGeom>
+        <a:solidFill>
+          <a:srgbClr val="00B050"/>
+        </a:solidFill>
+        <a:ln w="12700" cap="flat" cmpd="sng" algn="ctr">
+          <a:solidFill>
+            <a:schemeClr val="lt1">
+              <a:hueOff val="0"/>
+              <a:satOff val="0"/>
+              <a:lumOff val="0"/>
+              <a:alphaOff val="0"/>
+            </a:schemeClr>
+          </a:solidFill>
+          <a:prstDash val="solid"/>
+          <a:miter lim="800000"/>
+        </a:ln>
+        <a:effectLst/>
+      </dsp:spPr>
+      <dsp:style>
+        <a:lnRef idx="2">
+          <a:scrgbClr r="0" g="0" b="0"/>
+        </a:lnRef>
+        <a:fillRef idx="1">
+          <a:scrgbClr r="0" g="0" b="0"/>
+        </a:fillRef>
+        <a:effectRef idx="0">
+          <a:scrgbClr r="0" g="0" b="0"/>
+        </a:effectRef>
+        <a:fontRef idx="minor">
+          <a:schemeClr val="lt1"/>
+        </a:fontRef>
+      </dsp:style>
+      <dsp:txBody>
+        <a:bodyPr spcFirstLastPara="0" vert="horz" wrap="square" lIns="60960" tIns="60960" rIns="60960" bIns="60960" numCol="1" spcCol="1270" anchor="ctr" anchorCtr="0">
+          <a:noAutofit/>
+        </a:bodyPr>
+        <a:lstStyle/>
+        <a:p>
+          <a:pPr marL="0" lvl="0" indent="0" algn="ctr" defTabSz="711200">
+            <a:lnSpc>
+              <a:spcPct val="90000"/>
+            </a:lnSpc>
+            <a:spcBef>
+              <a:spcPct val="0"/>
+            </a:spcBef>
+            <a:spcAft>
+              <a:spcPct val="35000"/>
+            </a:spcAft>
+            <a:buNone/>
+          </a:pPr>
+          <a:r>
+            <a:rPr lang="en-GB" sz="1600" kern="1200"/>
+            <a:t>generate_summary_in_excel.R</a:t>
+          </a:r>
+        </a:p>
+      </dsp:txBody>
+      <dsp:txXfrm>
+        <a:off x="106367" y="4923138"/>
+        <a:ext cx="2784450" cy="1670670"/>
       </dsp:txXfrm>
     </dsp:sp>
     <dsp:sp modelId="{4039EB67-CC04-40F0-A707-A3A076A1A7A9}">
@@ -2349,8 +2362,8 @@
       </dsp:nvSpPr>
       <dsp:spPr>
         <a:xfrm>
-          <a:off x="7190486" y="5170777"/>
-          <a:ext cx="2459260" cy="1475556"/>
+          <a:off x="9195707" y="4960847"/>
+          <a:ext cx="2784450" cy="1670670"/>
         </a:xfrm>
         <a:prstGeom prst="rect">
           <a:avLst/>
@@ -2392,12 +2405,12 @@
         </a:fontRef>
       </dsp:style>
       <dsp:txBody>
-        <a:bodyPr spcFirstLastPara="0" vert="horz" wrap="square" lIns="64770" tIns="64770" rIns="64770" bIns="64770" numCol="1" spcCol="1270" anchor="ctr" anchorCtr="0">
+        <a:bodyPr spcFirstLastPara="0" vert="horz" wrap="square" lIns="60960" tIns="60960" rIns="60960" bIns="60960" numCol="1" spcCol="1270" anchor="ctr" anchorCtr="0">
           <a:noAutofit/>
         </a:bodyPr>
         <a:lstStyle/>
         <a:p>
-          <a:pPr marL="0" lvl="0" indent="0" algn="ctr" defTabSz="755650">
+          <a:pPr marL="0" lvl="0" indent="0" algn="ctr" defTabSz="711200">
             <a:lnSpc>
               <a:spcPct val="90000"/>
             </a:lnSpc>
@@ -2410,15 +2423,15 @@
             <a:buNone/>
           </a:pPr>
           <a:r>
-            <a:rPr lang="en-GB" sz="1700" kern="1200" dirty="0" err="1"/>
+            <a:rPr lang="en-GB" sz="1600" kern="1200" dirty="0" err="1"/>
             <a:t>late_lookup_edits.R</a:t>
           </a:r>
-          <a:endParaRPr lang="en-GB" sz="1700" kern="1200" dirty="0"/>
+          <a:endParaRPr lang="en-GB" sz="1600" kern="1200" dirty="0"/>
         </a:p>
       </dsp:txBody>
       <dsp:txXfrm>
-        <a:off x="7190486" y="5170777"/>
-        <a:ext cx="2459260" cy="1475556"/>
+        <a:off x="9195707" y="4960847"/>
+        <a:ext cx="2784450" cy="1670670"/>
       </dsp:txXfrm>
     </dsp:sp>
     <dsp:sp modelId="{D46FE4A4-C409-41F8-AC0E-1A8D4F4172F5}">
@@ -2428,8 +2441,8 @@
       </dsp:nvSpPr>
       <dsp:spPr>
         <a:xfrm>
-          <a:off x="4064003" y="1611610"/>
-          <a:ext cx="2459260" cy="1475556"/>
+          <a:off x="3369242" y="2672612"/>
+          <a:ext cx="2784450" cy="1670670"/>
         </a:xfrm>
         <a:prstGeom prst="rect">
           <a:avLst/>
@@ -2469,12 +2482,12 @@
         </a:fontRef>
       </dsp:style>
       <dsp:txBody>
-        <a:bodyPr spcFirstLastPara="0" vert="horz" wrap="square" lIns="64770" tIns="64770" rIns="64770" bIns="64770" numCol="1" spcCol="1270" anchor="ctr" anchorCtr="0">
+        <a:bodyPr spcFirstLastPara="0" vert="horz" wrap="square" lIns="60960" tIns="60960" rIns="60960" bIns="60960" numCol="1" spcCol="1270" anchor="ctr" anchorCtr="0">
           <a:noAutofit/>
         </a:bodyPr>
         <a:lstStyle/>
         <a:p>
-          <a:pPr marL="0" lvl="0" indent="0" algn="ctr" defTabSz="755650">
+          <a:pPr marL="0" lvl="0" indent="0" algn="ctr" defTabSz="711200">
             <a:lnSpc>
               <a:spcPct val="90000"/>
             </a:lnSpc>
@@ -2487,15 +2500,15 @@
             <a:buNone/>
           </a:pPr>
           <a:r>
-            <a:rPr lang="en-GB" sz="1700" kern="1200" dirty="0" err="1"/>
+            <a:rPr lang="en-GB" sz="1600" kern="1200" dirty="0" err="1"/>
             <a:t>packages.R</a:t>
           </a:r>
-          <a:endParaRPr lang="en-GB" sz="1700" kern="1200" dirty="0"/>
+          <a:endParaRPr lang="en-GB" sz="1600" kern="1200" dirty="0"/>
         </a:p>
       </dsp:txBody>
       <dsp:txXfrm>
-        <a:off x="4064003" y="1611610"/>
-        <a:ext cx="2459260" cy="1475556"/>
+        <a:off x="3369242" y="2672612"/>
+        <a:ext cx="2784450" cy="1670670"/>
       </dsp:txXfrm>
     </dsp:sp>
   </dsp:spTree>
@@ -3832,7 +3845,7 @@
           <a:p>
             <a:fld id="{32DB8739-93B9-4CB5-B22C-3EE500986FCD}" type="datetimeFigureOut">
               <a:rPr lang="en-GB" smtClean="0"/>
-              <a:t>07/03/2024</a:t>
+              <a:t>18/09/2026</a:t>
             </a:fld>
             <a:endParaRPr lang="en-GB"/>
           </a:p>
@@ -4032,7 +4045,7 @@
           <a:p>
             <a:fld id="{32DB8739-93B9-4CB5-B22C-3EE500986FCD}" type="datetimeFigureOut">
               <a:rPr lang="en-GB" smtClean="0"/>
-              <a:t>07/03/2024</a:t>
+              <a:t>18/09/2026</a:t>
             </a:fld>
             <a:endParaRPr lang="en-GB"/>
           </a:p>
@@ -4242,7 +4255,7 @@
           <a:p>
             <a:fld id="{32DB8739-93B9-4CB5-B22C-3EE500986FCD}" type="datetimeFigureOut">
               <a:rPr lang="en-GB" smtClean="0"/>
-              <a:t>07/03/2024</a:t>
+              <a:t>18/09/2026</a:t>
             </a:fld>
             <a:endParaRPr lang="en-GB"/>
           </a:p>
@@ -4442,7 +4455,7 @@
           <a:p>
             <a:fld id="{32DB8739-93B9-4CB5-B22C-3EE500986FCD}" type="datetimeFigureOut">
               <a:rPr lang="en-GB" smtClean="0"/>
-              <a:t>07/03/2024</a:t>
+              <a:t>18/09/2026</a:t>
             </a:fld>
             <a:endParaRPr lang="en-GB"/>
           </a:p>
@@ -4718,7 +4731,7 @@
           <a:p>
             <a:fld id="{32DB8739-93B9-4CB5-B22C-3EE500986FCD}" type="datetimeFigureOut">
               <a:rPr lang="en-GB" smtClean="0"/>
-              <a:t>07/03/2024</a:t>
+              <a:t>18/09/2026</a:t>
             </a:fld>
             <a:endParaRPr lang="en-GB"/>
           </a:p>
@@ -4986,7 +4999,7 @@
           <a:p>
             <a:fld id="{32DB8739-93B9-4CB5-B22C-3EE500986FCD}" type="datetimeFigureOut">
               <a:rPr lang="en-GB" smtClean="0"/>
-              <a:t>07/03/2024</a:t>
+              <a:t>18/09/2026</a:t>
             </a:fld>
             <a:endParaRPr lang="en-GB"/>
           </a:p>
@@ -5401,7 +5414,7 @@
           <a:p>
             <a:fld id="{32DB8739-93B9-4CB5-B22C-3EE500986FCD}" type="datetimeFigureOut">
               <a:rPr lang="en-GB" smtClean="0"/>
-              <a:t>07/03/2024</a:t>
+              <a:t>18/09/2026</a:t>
             </a:fld>
             <a:endParaRPr lang="en-GB"/>
           </a:p>
@@ -5543,7 +5556,7 @@
           <a:p>
             <a:fld id="{32DB8739-93B9-4CB5-B22C-3EE500986FCD}" type="datetimeFigureOut">
               <a:rPr lang="en-GB" smtClean="0"/>
-              <a:t>07/03/2024</a:t>
+              <a:t>18/09/2026</a:t>
             </a:fld>
             <a:endParaRPr lang="en-GB"/>
           </a:p>
@@ -5656,7 +5669,7 @@
           <a:p>
             <a:fld id="{32DB8739-93B9-4CB5-B22C-3EE500986FCD}" type="datetimeFigureOut">
               <a:rPr lang="en-GB" smtClean="0"/>
-              <a:t>07/03/2024</a:t>
+              <a:t>18/09/2026</a:t>
             </a:fld>
             <a:endParaRPr lang="en-GB"/>
           </a:p>
@@ -5969,7 +5982,7 @@
           <a:p>
             <a:fld id="{32DB8739-93B9-4CB5-B22C-3EE500986FCD}" type="datetimeFigureOut">
               <a:rPr lang="en-GB" smtClean="0"/>
-              <a:t>07/03/2024</a:t>
+              <a:t>18/09/2026</a:t>
             </a:fld>
             <a:endParaRPr lang="en-GB"/>
           </a:p>
@@ -6258,7 +6271,7 @@
           <a:p>
             <a:fld id="{32DB8739-93B9-4CB5-B22C-3EE500986FCD}" type="datetimeFigureOut">
               <a:rPr lang="en-GB" smtClean="0"/>
-              <a:t>07/03/2024</a:t>
+              <a:t>18/09/2026</a:t>
             </a:fld>
             <a:endParaRPr lang="en-GB"/>
           </a:p>
@@ -6501,7 +6514,7 @@
           <a:p>
             <a:fld id="{32DB8739-93B9-4CB5-B22C-3EE500986FCD}" type="datetimeFigureOut">
               <a:rPr lang="en-GB" smtClean="0"/>
-              <a:t>07/03/2024</a:t>
+              <a:t>18/09/2026</a:t>
             </a:fld>
             <a:endParaRPr lang="en-GB"/>
           </a:p>
@@ -7017,14 +7030,14 @@
           <p:nvPr>
             <p:extLst>
               <p:ext uri="{D42A27DB-BD31-4B8C-83A1-F6EECF244321}">
-                <p14:modId xmlns:p14="http://schemas.microsoft.com/office/powerpoint/2010/main" val="4084367073"/>
+                <p14:modId xmlns:p14="http://schemas.microsoft.com/office/powerpoint/2010/main" val="946761244"/>
               </p:ext>
             </p:extLst>
           </p:nvPr>
         </p:nvGraphicFramePr>
         <p:xfrm>
-          <a:off x="2032000" y="97366"/>
-          <a:ext cx="10033000" cy="6646334"/>
+          <a:off x="84842" y="105833"/>
+          <a:ext cx="11980158" cy="6631518"/>
         </p:xfrm>
         <a:graphic>
           <a:graphicData uri="http://schemas.openxmlformats.org/drawingml/2006/diagram">
@@ -7046,13 +7059,13 @@
         </p:nvSpPr>
         <p:spPr>
           <a:xfrm>
-            <a:off x="812800" y="5321300"/>
-            <a:ext cx="1905000" cy="838200"/>
+            <a:off x="2361545" y="105833"/>
+            <a:ext cx="1937077" cy="1034941"/>
           </a:xfrm>
           <a:prstGeom prst="wedgeRectCallout">
             <a:avLst>
-              <a:gd name="adj1" fmla="val 44588"/>
-              <a:gd name="adj2" fmla="val -110227"/>
+              <a:gd name="adj1" fmla="val 8077"/>
+              <a:gd name="adj2" fmla="val 68403"/>
             </a:avLst>
           </a:prstGeom>
           <a:noFill/>
@@ -7091,7 +7104,7 @@
                   </a:schemeClr>
                 </a:solidFill>
               </a:rPr>
-              <a:t>Core scripts to be run one at a time. </a:t>
+              <a:t>Core scripts, to be run one-at-a-time. </a:t>
             </a:r>
           </a:p>
           <a:p>
@@ -7120,13 +7133,13 @@
         </p:nvSpPr>
         <p:spPr>
           <a:xfrm>
-            <a:off x="8775700" y="317500"/>
+            <a:off x="3864989" y="1604909"/>
             <a:ext cx="1905000" cy="990600"/>
           </a:xfrm>
           <a:prstGeom prst="wedgeRectCallout">
             <a:avLst>
-              <a:gd name="adj1" fmla="val -60079"/>
-              <a:gd name="adj2" fmla="val -39015"/>
+              <a:gd name="adj1" fmla="val -18017"/>
+              <a:gd name="adj2" fmla="val 69470"/>
             </a:avLst>
           </a:prstGeom>
           <a:noFill/>
@@ -7163,7 +7176,7 @@
                   <a:schemeClr val="tx1"/>
                 </a:solidFill>
               </a:rPr>
-              <a:t>Code that is called from other scripts.</a:t>
+              <a:t>Code that’s called from other scripts.</a:t>
             </a:r>
           </a:p>
           <a:p>
@@ -7190,13 +7203,13 @@
         </p:nvSpPr>
         <p:spPr>
           <a:xfrm>
-            <a:off x="10795000" y="952500"/>
+            <a:off x="8138176" y="213891"/>
             <a:ext cx="1270000" cy="601134"/>
           </a:xfrm>
           <a:prstGeom prst="wedgeRectCallout">
             <a:avLst>
-              <a:gd name="adj1" fmla="val 4588"/>
-              <a:gd name="adj2" fmla="val 102010"/>
+              <a:gd name="adj1" fmla="val 56546"/>
+              <a:gd name="adj2" fmla="val 130238"/>
             </a:avLst>
           </a:prstGeom>
           <a:noFill/>
@@ -7262,13 +7275,13 @@
         </p:nvSpPr>
         <p:spPr>
           <a:xfrm>
-            <a:off x="6210300" y="3327400"/>
-            <a:ext cx="2959100" cy="393700"/>
+            <a:off x="6873937" y="2125350"/>
+            <a:ext cx="2306687" cy="952106"/>
           </a:xfrm>
           <a:prstGeom prst="wedgeRectCallout">
             <a:avLst>
-              <a:gd name="adj1" fmla="val 34202"/>
-              <a:gd name="adj2" fmla="val 332445"/>
+              <a:gd name="adj1" fmla="val 18190"/>
+              <a:gd name="adj2" fmla="val 88094"/>
             </a:avLst>
           </a:prstGeom>
           <a:noFill/>
@@ -7404,7 +7417,9 @@
         </p:nvSpPr>
         <p:spPr/>
         <p:txBody>
-          <a:bodyPr/>
+          <a:bodyPr>
+            <a:normAutofit/>
+          </a:bodyPr>
           <a:lstStyle/>
           <a:p>
             <a:pPr marL="514350" indent="-514350">
@@ -7433,78 +7448,47 @@
             </a:pPr>
             <a:r>
               <a:rPr lang="en-GB"/>
-              <a:t>Run code:</a:t>
-            </a:r>
-          </a:p>
-          <a:p>
-            <a:pPr lvl="1">
-              <a:buFont typeface="Wingdings" panose="05000000000000000000" pitchFamily="2" charset="2"/>
-              <a:buChar char="§"/>
+              <a:t>Extract data (BOXI)</a:t>
+            </a:r>
+          </a:p>
+          <a:p>
+            <a:pPr marL="514350" indent="-514350">
+              <a:buFont typeface="+mj-lt"/>
+              <a:buAutoNum type="arabicPeriod"/>
             </a:pPr>
             <a:r>
               <a:rPr lang="en-GB"/>
-              <a:t>housekeeping.R</a:t>
-            </a:r>
-          </a:p>
-          <a:p>
-            <a:pPr lvl="1">
-              <a:buFont typeface="Wingdings" panose="05000000000000000000" pitchFamily="2" charset="2"/>
-              <a:buChar char="§"/>
+              <a:t>Run code</a:t>
+            </a:r>
+          </a:p>
+          <a:p>
+            <a:pPr marL="514350" indent="-514350">
+              <a:buFont typeface="+mj-lt"/>
+              <a:buAutoNum type="arabicPeriod"/>
             </a:pPr>
             <a:r>
               <a:rPr lang="en-GB"/>
-              <a:t>create_lookup.R </a:t>
-            </a:r>
-          </a:p>
-          <a:p>
-            <a:pPr lvl="1">
-              <a:buFont typeface="Wingdings" panose="05000000000000000000" pitchFamily="2" charset="2"/>
-              <a:buChar char="§"/>
+              <a:t>Update Tableau</a:t>
+            </a:r>
+          </a:p>
+          <a:p>
+            <a:pPr marL="514350" indent="-514350">
+              <a:buFont typeface="+mj-lt"/>
+              <a:buAutoNum type="arabicPeriod"/>
             </a:pPr>
             <a:r>
-              <a:rPr lang="en-GB"/>
-              <a:t>create_templates.R</a:t>
-            </a:r>
-          </a:p>
-          <a:p>
-            <a:pPr lvl="1">
-              <a:buFont typeface="Wingdings" panose="05000000000000000000" pitchFamily="2" charset="2"/>
-              <a:buChar char="§"/>
+              <a:rPr lang="en-GB">
+                <a:latin typeface="Calibri" panose="020F0502020204030204" pitchFamily="34" charset="0"/>
+                <a:cs typeface="Times New Roman" panose="02020603050405020304" pitchFamily="18" charset="0"/>
+              </a:rPr>
+              <a:t>Pull Request GitHub Changes and Create Release</a:t>
+            </a:r>
+          </a:p>
+          <a:p>
+            <a:pPr marL="0" indent="0">
+              <a:buNone/>
             </a:pPr>
-            <a:r>
-              <a:rPr lang="en-GB"/>
-              <a:t>check_submissions.R </a:t>
-            </a:r>
-          </a:p>
-          <a:p>
-            <a:pPr lvl="1">
-              <a:buFont typeface="Wingdings" panose="05000000000000000000" pitchFamily="2" charset="2"/>
-              <a:buChar char="§"/>
-            </a:pPr>
-            <a:r>
-              <a:rPr lang="en-GB"/>
-              <a:t>hb_hosp_qpi.R</a:t>
-            </a:r>
-          </a:p>
-          <a:p>
-            <a:pPr lvl="1">
-              <a:buFont typeface="Wingdings" panose="05000000000000000000" pitchFamily="2" charset="2"/>
-              <a:buChar char="§"/>
-            </a:pPr>
-            <a:r>
-              <a:rPr lang="en-GB"/>
-              <a:t>age_gender.R</a:t>
-            </a:r>
-          </a:p>
-          <a:p>
-            <a:pPr lvl="1">
-              <a:buFont typeface="Wingdings" panose="05000000000000000000" pitchFamily="2" charset="2"/>
-              <a:buChar char="§"/>
-            </a:pPr>
-            <a:r>
-              <a:rPr lang="en-GB"/>
-              <a:t>case_asc.R</a:t>
-            </a:r>
+            <a:endParaRPr lang="en-GB"/>
           </a:p>
         </p:txBody>
       </p:sp>
@@ -7560,17 +7544,10 @@
           <a:lstStyle/>
           <a:p>
             <a:r>
-              <a:rPr lang="en-GB" dirty="0"/>
-              <a:t>Summary </a:t>
-            </a:r>
-            <a:r>
               <a:rPr lang="en-GB"/>
-              <a:t>of steps </a:t>
-            </a:r>
-            <a:r>
-              <a:rPr lang="en-GB" dirty="0"/>
-              <a:t>in the SOP</a:t>
-            </a:r>
+              <a:t>Step 4 Run code </a:t>
+            </a:r>
+            <a:endParaRPr lang="en-GB" dirty="0"/>
           </a:p>
         </p:txBody>
       </p:sp>
@@ -7592,12 +7569,14 @@
         </p:nvSpPr>
         <p:spPr/>
         <p:txBody>
-          <a:bodyPr/>
+          <a:bodyPr>
+            <a:normAutofit fontScale="92500" lnSpcReduction="10000"/>
+          </a:bodyPr>
           <a:lstStyle/>
           <a:p>
-            <a:pPr marL="514350" indent="-514350">
+            <a:pPr marL="457200" lvl="1" indent="-457200">
               <a:buFont typeface="+mj-lt"/>
-              <a:buAutoNum type="arabicPeriod"/>
+              <a:buAutoNum type="arabicPeriod" startAt="4"/>
             </a:pPr>
             <a:r>
               <a:rPr lang="en-GB"/>
@@ -7605,93 +7584,91 @@
             </a:r>
           </a:p>
           <a:p>
+            <a:pPr lvl="1"/>
+            <a:r>
+              <a:rPr lang="en-GB"/>
+              <a:t>housekeeping.R</a:t>
+            </a:r>
+          </a:p>
+          <a:p>
+            <a:pPr lvl="1"/>
+            <a:r>
+              <a:rPr lang="en-GB"/>
+              <a:t>create_lookup.R </a:t>
+            </a:r>
+          </a:p>
+          <a:p>
+            <a:pPr lvl="1"/>
+            <a:r>
+              <a:rPr lang="en-GB"/>
+              <a:t>check_extracts.R </a:t>
+            </a:r>
+          </a:p>
+          <a:p>
+            <a:pPr lvl="1"/>
+            <a:r>
+              <a:rPr lang="en-GB"/>
+              <a:t>hb_hosp_qpi.R</a:t>
+            </a:r>
+          </a:p>
+          <a:p>
+            <a:pPr lvl="1"/>
+            <a:r>
+              <a:rPr lang="en-GB"/>
+              <a:t>age_gender.R</a:t>
+            </a:r>
+          </a:p>
+          <a:p>
+            <a:pPr lvl="1"/>
+            <a:r>
+              <a:rPr lang="en-GB"/>
+              <a:t>case_asc.R</a:t>
+            </a:r>
+          </a:p>
+          <a:p>
+            <a:pPr marL="457200" lvl="1" indent="0">
+              <a:buNone/>
+            </a:pPr>
+            <a:endParaRPr lang="en-GB"/>
+          </a:p>
+          <a:p>
+            <a:pPr>
+              <a:buFont typeface="Wingdings" panose="05000000000000000000" pitchFamily="2" charset="2"/>
+              <a:buChar char="v"/>
+            </a:pPr>
+            <a:r>
+              <a:rPr lang="en-GB"/>
+              <a:t>Optional: </a:t>
+            </a:r>
+          </a:p>
+          <a:p>
             <a:pPr lvl="1">
               <a:buFont typeface="Wingdings" panose="05000000000000000000" pitchFamily="2" charset="2"/>
-              <a:buChar char="§"/>
+              <a:buChar char="q"/>
             </a:pPr>
             <a:r>
               <a:rPr lang="en-GB"/>
-              <a:t>housekeeping.R</a:t>
+              <a:t>change_qpi_names.R </a:t>
             </a:r>
           </a:p>
           <a:p>
             <a:pPr lvl="1">
               <a:buFont typeface="Wingdings" panose="05000000000000000000" pitchFamily="2" charset="2"/>
-              <a:buChar char="§"/>
+              <a:buChar char="q"/>
             </a:pPr>
             <a:r>
               <a:rPr lang="en-GB"/>
-              <a:t>create_lookup.R </a:t>
+              <a:t>change_hospital_names.R </a:t>
             </a:r>
           </a:p>
           <a:p>
             <a:pPr lvl="1">
               <a:buFont typeface="Wingdings" panose="05000000000000000000" pitchFamily="2" charset="2"/>
-              <a:buChar char="§"/>
+              <a:buChar char="q"/>
             </a:pPr>
             <a:r>
               <a:rPr lang="en-GB"/>
-              <a:t>create_templates.R</a:t>
-            </a:r>
-          </a:p>
-          <a:p>
-            <a:pPr lvl="1">
-              <a:buFont typeface="Wingdings" panose="05000000000000000000" pitchFamily="2" charset="2"/>
-              <a:buChar char="§"/>
-            </a:pPr>
-            <a:r>
-              <a:rPr lang="en-GB"/>
-              <a:t>check_submissions.R </a:t>
-            </a:r>
-          </a:p>
-          <a:p>
-            <a:pPr lvl="1">
-              <a:buFont typeface="Wingdings" panose="05000000000000000000" pitchFamily="2" charset="2"/>
-              <a:buChar char="§"/>
-            </a:pPr>
-            <a:r>
-              <a:rPr lang="en-GB"/>
-              <a:t>hb_hosp_qpi.R</a:t>
-            </a:r>
-          </a:p>
-          <a:p>
-            <a:pPr lvl="1">
-              <a:buFont typeface="Wingdings" panose="05000000000000000000" pitchFamily="2" charset="2"/>
-              <a:buChar char="§"/>
-            </a:pPr>
-            <a:r>
-              <a:rPr lang="en-GB"/>
-              <a:t>age_gender.R</a:t>
-            </a:r>
-          </a:p>
-          <a:p>
-            <a:pPr lvl="1">
-              <a:buFont typeface="Wingdings" panose="05000000000000000000" pitchFamily="2" charset="2"/>
-              <a:buChar char="§"/>
-            </a:pPr>
-            <a:r>
-              <a:rPr lang="en-GB"/>
-              <a:t>case_asc.R</a:t>
-            </a:r>
-          </a:p>
-          <a:p>
-            <a:pPr>
-              <a:buFont typeface="Wingdings" panose="05000000000000000000" pitchFamily="2" charset="2"/>
-              <a:buChar char="§"/>
-            </a:pPr>
-            <a:r>
-              <a:rPr lang="en-GB"/>
-              <a:t>Optional: </a:t>
-            </a:r>
-          </a:p>
-          <a:p>
-            <a:pPr lvl="1">
-              <a:buFont typeface="Wingdings" panose="05000000000000000000" pitchFamily="2" charset="2"/>
-              <a:buChar char="§"/>
-            </a:pPr>
-            <a:r>
-              <a:rPr lang="en-GB"/>
-              <a:t>change_qpi_names.R / change_hospital_names.R / late_lookup_edits.R</a:t>
+              <a:t>late_lookup_edits.R</a:t>
             </a:r>
           </a:p>
         </p:txBody>
@@ -7700,154 +7677,6 @@
     <p:extLst>
       <p:ext uri="{BB962C8B-B14F-4D97-AF65-F5344CB8AC3E}">
         <p14:creationId xmlns:p14="http://schemas.microsoft.com/office/powerpoint/2010/main" val="3977691794"/>
-      </p:ext>
-    </p:extLst>
-  </p:cSld>
-  <p:clrMapOvr>
-    <a:masterClrMapping/>
-  </p:clrMapOvr>
-</p:sld>
-</file>
-
-<file path=ppt/slides/slide5.xml><?xml version="1.0" encoding="utf-8"?>
-<p:sld xmlns:a="http://schemas.openxmlformats.org/drawingml/2006/main" xmlns:r="http://schemas.openxmlformats.org/officeDocument/2006/relationships" xmlns:p="http://schemas.openxmlformats.org/presentationml/2006/main">
-  <p:cSld>
-    <p:spTree>
-      <p:nvGrpSpPr>
-        <p:cNvPr id="1" name=""/>
-        <p:cNvGrpSpPr/>
-        <p:nvPr/>
-      </p:nvGrpSpPr>
-      <p:grpSpPr>
-        <a:xfrm>
-          <a:off x="0" y="0"/>
-          <a:ext cx="0" cy="0"/>
-          <a:chOff x="0" y="0"/>
-          <a:chExt cx="0" cy="0"/>
-        </a:xfrm>
-      </p:grpSpPr>
-      <p:sp>
-        <p:nvSpPr>
-          <p:cNvPr id="2" name="Title 1">
-            <a:extLst>
-              <a:ext uri="{FF2B5EF4-FFF2-40B4-BE49-F238E27FC236}">
-                <a16:creationId xmlns:a16="http://schemas.microsoft.com/office/drawing/2014/main" id="{4A423E10-009B-3EAE-6194-8050B48A8190}"/>
-              </a:ext>
-            </a:extLst>
-          </p:cNvPr>
-          <p:cNvSpPr>
-            <a:spLocks noGrp="1"/>
-          </p:cNvSpPr>
-          <p:nvPr>
-            <p:ph type="title"/>
-          </p:nvPr>
-        </p:nvSpPr>
-        <p:spPr/>
-        <p:txBody>
-          <a:bodyPr/>
-          <a:lstStyle/>
-          <a:p>
-            <a:r>
-              <a:rPr lang="en-GB" dirty="0"/>
-              <a:t>Summary </a:t>
-            </a:r>
-            <a:r>
-              <a:rPr lang="en-GB"/>
-              <a:t>of steps </a:t>
-            </a:r>
-            <a:r>
-              <a:rPr lang="en-GB" dirty="0"/>
-              <a:t>in the SOP</a:t>
-            </a:r>
-          </a:p>
-        </p:txBody>
-      </p:sp>
-      <p:sp>
-        <p:nvSpPr>
-          <p:cNvPr id="3" name="Content Placeholder 2">
-            <a:extLst>
-              <a:ext uri="{FF2B5EF4-FFF2-40B4-BE49-F238E27FC236}">
-                <a16:creationId xmlns:a16="http://schemas.microsoft.com/office/drawing/2014/main" id="{94D823C6-B5B8-CF4C-8113-1E49B47EFD57}"/>
-              </a:ext>
-            </a:extLst>
-          </p:cNvPr>
-          <p:cNvSpPr>
-            <a:spLocks noGrp="1"/>
-          </p:cNvSpPr>
-          <p:nvPr>
-            <p:ph idx="1"/>
-          </p:nvPr>
-        </p:nvSpPr>
-        <p:spPr/>
-        <p:txBody>
-          <a:bodyPr/>
-          <a:lstStyle/>
-          <a:p>
-            <a:pPr marL="514350" indent="-514350">
-              <a:buFont typeface="+mj-lt"/>
-              <a:buAutoNum type="arabicPeriod"/>
-            </a:pPr>
-            <a:r>
-              <a:rPr lang="en-GB"/>
-              <a:t>Set up folders</a:t>
-            </a:r>
-          </a:p>
-          <a:p>
-            <a:pPr marL="514350" indent="-514350">
-              <a:buFont typeface="+mj-lt"/>
-              <a:buAutoNum type="arabicPeriod"/>
-            </a:pPr>
-            <a:r>
-              <a:rPr lang="en-GB"/>
-              <a:t>Create lookup</a:t>
-            </a:r>
-          </a:p>
-          <a:p>
-            <a:pPr marL="514350" indent="-514350">
-              <a:buFont typeface="+mj-lt"/>
-              <a:buAutoNum type="arabicPeriod"/>
-            </a:pPr>
-            <a:r>
-              <a:rPr lang="en-GB"/>
-              <a:t>Run code</a:t>
-            </a:r>
-          </a:p>
-          <a:p>
-            <a:pPr marL="514350" indent="-514350">
-              <a:buFont typeface="+mj-lt"/>
-              <a:buAutoNum type="arabicPeriod"/>
-            </a:pPr>
-            <a:r>
-              <a:rPr lang="en-GB"/>
-              <a:t>Update Tableau</a:t>
-            </a:r>
-          </a:p>
-          <a:p>
-            <a:pPr marL="514350" indent="-514350">
-              <a:buFont typeface="+mj-lt"/>
-              <a:buAutoNum type="arabicPeriod"/>
-            </a:pPr>
-            <a:r>
-              <a:rPr lang="en-GB" sz="2800">
-                <a:effectLst/>
-                <a:latin typeface="Calibri" panose="020F0502020204030204" pitchFamily="34" charset="0"/>
-                <a:cs typeface="Times New Roman" panose="02020603050405020304" pitchFamily="18" charset="0"/>
-              </a:rPr>
-              <a:t>Pull Request GitHub Changes and Create Release</a:t>
-            </a:r>
-          </a:p>
-          <a:p>
-            <a:pPr marL="0" indent="0">
-              <a:buNone/>
-            </a:pPr>
-            <a:endParaRPr lang="en-GB"/>
-          </a:p>
-        </p:txBody>
-      </p:sp>
-    </p:spTree>
-    <p:extLst>
-      <p:ext uri="{BB962C8B-B14F-4D97-AF65-F5344CB8AC3E}">
-        <p14:creationId xmlns:p14="http://schemas.microsoft.com/office/powerpoint/2010/main" val="1101603778"/>
       </p:ext>
     </p:extLst>
   </p:cSld>
@@ -8154,6 +7983,6 @@
 
 <file path=docMetadata/LabelInfo.xml><?xml version="1.0" encoding="utf-8"?>
 <clbl:labelList xmlns:clbl="http://schemas.microsoft.com/office/2020/mipLabelMetadata">
-  <clbl:label id="{10efe0bd-a030-4bca-809c-b5e6745e499a}" enabled="0" method="" siteId="{10efe0bd-a030-4bca-809c-b5e6745e499a}" removed="1"/>
+  <clbl:label id="{b4199b9c-a89e-442f-9799-431511f14748}" enabled="1" method="Privileged" siteId="{10efe0bd-a030-4bca-809c-b5e6745e499a}" contentBits="0" removed="0"/>
 </clbl:labelList>
 </file>
</xml_diff>